<commit_message>
minimal change on fronts _Oybek
</commit_message>
<xml_diff>
--- a/FINAL_0512_Stablecoin_Exorbitant_Privilege.pptx
+++ b/FINAL_0512_Stablecoin_Exorbitant_Privilege.pptx
@@ -124,7 +124,7 @@
   <p:extLst>
     <p:ext uri="{EFAFB233-063F-42B5-8137-9DF3F51BA10A}">
       <p15:sldGuideLst xmlns:p15="http://schemas.microsoft.com/office/powerpoint/2012/main">
-        <p15:guide id="1" orient="horz" pos="2090" userDrawn="1">
+        <p15:guide id="1" orient="horz" pos="2119" userDrawn="1">
           <p15:clr>
             <a:srgbClr val="A4A3A4"/>
           </p15:clr>
@@ -13482,7 +13482,7 @@
         <p:spPr>
           <a:xfrm>
             <a:off x="6263005" y="3336290"/>
-            <a:ext cx="5624195" cy="384175"/>
+            <a:ext cx="5668645" cy="384175"/>
           </a:xfrm>
           <a:prstGeom prst="rect">
             <a:avLst/>
@@ -13525,7 +13525,7 @@
         <p:spPr>
           <a:xfrm>
             <a:off x="6366510" y="3375025"/>
-            <a:ext cx="5532755" cy="306705"/>
+            <a:ext cx="5319395" cy="306705"/>
           </a:xfrm>
           <a:prstGeom prst="rect">
             <a:avLst/>
@@ -14833,7 +14833,7 @@
         <p:spPr>
           <a:xfrm>
             <a:off x="2455545" y="3830320"/>
-            <a:ext cx="6411595" cy="306705"/>
+            <a:ext cx="6230620" cy="306705"/>
           </a:xfrm>
           <a:prstGeom prst="rect">
             <a:avLst/>
@@ -14986,6 +14986,14 @@
               </a:rPr>
               <a:t>	•	L &lt; L* → forced liquidation, sovereign spread disruption</a:t>
             </a:r>
+            <a:br>
+              <a:rPr lang="en-US" altLang="en-US" sz="1300" b="0" i="0">
+                <a:solidFill>
+                  <a:srgbClr val="1A1A2E"/>
+                </a:solidFill>
+                <a:latin typeface="Calibri"/>
+              </a:rPr>
+            </a:br>
             <a:endParaRPr lang="en-US" altLang="en-US" sz="1300" b="0" i="0">
               <a:solidFill>
                 <a:srgbClr val="1A1A2E"/>

</xml_diff>

<commit_message>
Added RQ and minimal minimal
</commit_message>
<xml_diff>
--- a/FINAL_0512_Stablecoin_Exorbitant_Privilege.pptx
+++ b/FINAL_0512_Stablecoin_Exorbitant_Privilege.pptx
@@ -124,7 +124,7 @@
   <p:extLst>
     <p:ext uri="{EFAFB233-063F-42B5-8137-9DF3F51BA10A}">
       <p15:sldGuideLst xmlns:p15="http://schemas.microsoft.com/office/powerpoint/2012/main">
-        <p15:guide id="1" orient="horz" pos="2160" userDrawn="1">
+        <p15:guide id="1" orient="horz" pos="2161" userDrawn="1">
           <p15:clr>
             <a:srgbClr val="A4A3A4"/>
           </p15:clr>
@@ -13012,8 +13012,8 @@
         </p:nvSpPr>
         <p:spPr>
           <a:xfrm>
-            <a:off x="358140" y="1516380"/>
-            <a:ext cx="11430000" cy="1424940"/>
+            <a:off x="358140" y="1292225"/>
+            <a:ext cx="11430000" cy="1649095"/>
           </a:xfrm>
           <a:prstGeom prst="rect">
             <a:avLst/>
@@ -13055,8 +13055,8 @@
         </p:nvSpPr>
         <p:spPr>
           <a:xfrm>
-            <a:off x="502920" y="1708785"/>
-            <a:ext cx="11155680" cy="1154430"/>
+            <a:off x="368935" y="1385570"/>
+            <a:ext cx="11410315" cy="1530985"/>
           </a:xfrm>
           <a:prstGeom prst="rect">
             <a:avLst/>
@@ -13069,31 +13069,71 @@
           </a:bodyPr>
           <a:lstStyle/>
           <a:p>
-            <a:pPr algn="l">
+            <a:pPr marL="342900" indent="-342900" algn="l">
               <a:spcBef>
                 <a:spcPts val="0"/>
               </a:spcBef>
+              <a:buFont typeface="Arial" panose="020B0704020202020204" pitchFamily="34" charset="0"/>
+              <a:buChar char="•"/>
             </a:pPr>
             <a:r>
-              <a:rPr lang="en-US" altLang="en-US" sz="1900" b="0" i="1" dirty="0">
+              <a:rPr lang="en-US" altLang="en-US" sz="1600" b="0" i="1" dirty="0">
                 <a:solidFill>
                   <a:srgbClr val="1A1A2E"/>
                 </a:solidFill>
                 <a:latin typeface="Calibri"/>
               </a:rPr>
-              <a:t>Bullet points about </a:t>
-            </a:r>
-            <a:r>
-              <a:rPr lang="en-US" altLang="en-US" sz="1900" b="1" i="1" dirty="0">
+              <a:t>The US issues the world's reserve currency — allowing it to borrow cheaply while investing in higher-yielding foreign assets</a:t>
+            </a:r>
+            <a:endParaRPr lang="en-US" altLang="en-US" sz="1600" b="0" i="1" dirty="0">
+              <a:solidFill>
+                <a:srgbClr val="1A1A2E"/>
+              </a:solidFill>
+              <a:latin typeface="Calibri"/>
+            </a:endParaRPr>
+          </a:p>
+          <a:p>
+            <a:pPr marL="342900" indent="-342900" algn="l">
+              <a:spcBef>
+                <a:spcPts val="0"/>
+              </a:spcBef>
+              <a:buFont typeface="Arial" panose="020B0704020202020204" pitchFamily="34" charset="0"/>
+              <a:buChar char="•"/>
+            </a:pPr>
+            <a:r>
+              <a:rPr lang="en-US" altLang="en-US" sz="1600" b="0" i="1" dirty="0">
                 <a:solidFill>
                   <a:srgbClr val="1A1A2E"/>
                 </a:solidFill>
                 <a:latin typeface="Calibri"/>
-                <a:sym typeface="+mn-ea"/>
-              </a:rPr>
-              <a:t> Exorbitant Privilege</a:t>
-            </a:r>
-            <a:endParaRPr lang="en-US" altLang="en-US" sz="1900" b="0" i="1" dirty="0">
+              </a:rPr>
+              <a:t>This "privilege" is measured through OIS–Treasury spread compression: when demand for T-bills rises, US borrowing costs fall below the market baseline</a:t>
+            </a:r>
+            <a:endParaRPr lang="en-US" altLang="en-US" sz="1600" b="0" i="1" dirty="0">
+              <a:solidFill>
+                <a:srgbClr val="1A1A2E"/>
+              </a:solidFill>
+              <a:latin typeface="Calibri"/>
+            </a:endParaRPr>
+          </a:p>
+          <a:p>
+            <a:pPr marL="342900" indent="-342900" algn="l">
+              <a:spcBef>
+                <a:spcPts val="0"/>
+              </a:spcBef>
+              <a:buFont typeface="Arial" panose="020B0704020202020204" pitchFamily="34" charset="0"/>
+              <a:buChar char="•"/>
+            </a:pPr>
+            <a:r>
+              <a:rPr lang="en-US" altLang="en-US" sz="1600" b="0" i="1" dirty="0">
+                <a:solidFill>
+                  <a:srgbClr val="1A1A2E"/>
+                </a:solidFill>
+                <a:latin typeface="Calibri"/>
+              </a:rPr>
+              <a:t>USD-pegged stablecoins now replicate this channel privately — creating $300bn+ in structural Treasury demand outside sovereign control</a:t>
+            </a:r>
+            <a:endParaRPr lang="en-US" altLang="en-US" sz="1600" b="0" i="1" dirty="0">
               <a:solidFill>
                 <a:srgbClr val="1A1A2E"/>
               </a:solidFill>
@@ -13239,7 +13279,7 @@
         </p:nvSpPr>
         <p:spPr>
           <a:xfrm>
-            <a:off x="482600" y="1158239"/>
+            <a:off x="482600" y="969644"/>
             <a:ext cx="11430000" cy="352425"/>
           </a:xfrm>
           <a:prstGeom prst="rect">
@@ -13261,7 +13301,7 @@
                 </a:solidFill>
                 <a:latin typeface="Calibri"/>
               </a:rPr>
-              <a:t>Research Topic</a:t>
+              <a:t>Exorbitant Privilege</a:t>
             </a:r>
             <a:endParaRPr lang="en-US" sz="1700" b="1" i="0">
               <a:solidFill>

</xml_diff>